<commit_message>
v2.1: Grammar, spelling and clarity fixes
- out-live -> outlive
- behaviours -> behaviors
- defence -> defense
- Curly quotes in demographics slide replaced with clean prose
- Slide 2 footer: removed dangling 'Focus:' sentence fragment
- Pattern table: Medical price level now shows (OECD = 100) for context
</commit_message>
<xml_diff>
--- a/health_expenditure_analysis.pptx
+++ b/health_expenditure_analysis.pptx
@@ -3794,7 +3794,7 @@
                   <a:srgbClr val="9CA3AF"/>
                 </a:solidFill>
               </a:rPr>
-              <a:t>Source: World Bank, World Development Indicators (health expenditure &amp; life expectancy, 2000–2023 averages). Focus: among the world’s highest spenders.</a:t>
+              <a:t>Source: World Bank, World Development Indicators (health expenditure &amp; life expectancy, 2000–2023 averages). Peer comparison restricted to the world’s highest-spending countries.</a:t>
             </a:r>
           </a:p>
         </p:txBody>
@@ -3919,7 +3919,7 @@
                   <a:srgbClr val="2BA88A"/>
                 </a:solidFill>
               </a:rPr>
-              <a:t>out-live</a:t>
+              <a:t>outlive</a:t>
             </a:r>
             <a:r>
               <a:rPr sz="2700" b="1">
@@ -4181,7 +4181,7 @@
                   <a:srgbClr val="4B5563"/>
                 </a:solidFill>
               </a:rPr>
-              <a:t>Skills predict the behaviours — diet,</a:t>
+              <a:t>Skills predict the behaviors — diet,</a:t>
             </a:r>
           </a:p>
           <a:p>
@@ -4928,18 +4928,7 @@
                   <a:srgbClr val="4B5563"/>
                 </a:solidFill>
               </a:rPr>
-              <a:t>A common defence: “Americans die younger</a:t>
-            </a:r>
-          </a:p>
-          <a:p>
-            <a:pPr algn="l"/>
-            <a:r>
-              <a:rPr sz="1200" b="0" i="0">
-                <a:solidFill>
-                  <a:srgbClr val="4B5563"/>
-                </a:solidFill>
-              </a:rPr>
-              <a:t>because the U.S. is different.”</a:t>
+              <a:t>Some argue demographics explain the gap — that the U.S. is simply younger.</a:t>
             </a:r>
           </a:p>
           <a:p>
@@ -6354,7 +6343,7 @@
                   <a:srgbClr val="374151"/>
                 </a:solidFill>
               </a:rPr>
-              <a:t>Medical price level</a:t>
+              <a:t>Medical price level (OECD = 100)</a:t>
             </a:r>
           </a:p>
         </p:txBody>

</xml_diff>